<commit_message>
docs: user guide, architecture, data dictionary, interview prep, LICENSE, CONTRIBUTING
</commit_message>
<xml_diff>
--- a/resources/Project_Deck.pptx
+++ b/resources/Project_Deck.pptx
@@ -17,9 +17,10 @@
     <p:sldId id="265" r:id="rId11"/>
     <p:sldId id="266" r:id="rId12"/>
     <p:sldId id="267" r:id="rId13"/>
+    <p:sldId id="268" r:id="rId14"/>
   </p:sldIdLst>
   <p:notesMasterIdLst>
-    <p:notesMasterId r:id="rId14"/>
+    <p:notesMasterId r:id="rId15"/>
   </p:notesMasterIdLst>
   <p:sldSz cx="12192000" cy="6858000"/>
   <p:notesSz cx="6858000" cy="12192000"/>
@@ -1404,7 +1405,7 @@
           <a:p>
             <a:r>
               <a:rPr lang="en-US" dirty="0"/>
-              <a:t>Leading with limitations builds credibility. Do not bury these.</a:t>
+              <a:t>This is the ML component. Frame the R2 correctly: the interesting part is the unexplained residual.</a:t>
             </a:r>
             <a:endParaRPr lang="en-US" dirty="0"/>
           </a:p>
@@ -1428,6 +1429,94 @@
             <a:fld id="{F7021451-1387-4CA6-816F-3879F97B5CBC}" type="slidenum">
               <a:rPr lang="en-US"/>
               <a:t>12</a:t>
+            </a:fld>
+            <a:endParaRPr lang="en-US"/>
+          </a:p>
+        </p:txBody>
+      </p:sp>
+    </p:spTree>
+    <p:extLst>
+      <p:ext uri="{BB962C8B-B14F-4D97-AF65-F5344CB8AC3E}">
+        <p14:creationId xmlns:p14="http://schemas.microsoft.com/office/powerpoint/2010/main" val="1024086991"/>
+      </p:ext>
+    </p:extLst>
+  </p:cSld>
+  <p:clrMapOvr>
+    <a:masterClrMapping/>
+  </p:clrMapOvr>
+</p:notes>
+</file>
+
+<file path=ppt/notesSlides/notesSlide13.xml><?xml version="1.0" encoding="utf-8"?>
+<p:notes xmlns:a="http://schemas.openxmlformats.org/drawingml/2006/main" xmlns:r="http://schemas.openxmlformats.org/officeDocument/2006/relationships" xmlns:p="http://schemas.openxmlformats.org/presentationml/2006/main">
+  <p:cSld>
+    <p:spTree>
+      <p:nvGrpSpPr>
+        <p:cNvPr id="1" name=""/>
+        <p:cNvGrpSpPr/>
+        <p:nvPr/>
+      </p:nvGrpSpPr>
+      <p:grpSpPr>
+        <a:xfrm>
+          <a:off x="0" y="0"/>
+          <a:ext cx="0" cy="0"/>
+          <a:chOff x="0" y="0"/>
+          <a:chExt cx="0" cy="0"/>
+        </a:xfrm>
+      </p:grpSpPr>
+      <p:sp>
+        <p:nvSpPr>
+          <p:cNvPr id="2" name="Slide Image Placeholder 1"/>
+          <p:cNvSpPr>
+            <a:spLocks noGrp="1" noRot="1" noChangeAspect="1"/>
+          </p:cNvSpPr>
+          <p:nvPr>
+            <p:ph type="sldImg"/>
+          </p:nvPr>
+        </p:nvSpPr>
+        <p:spPr/>
+      </p:sp>
+      <p:sp>
+        <p:nvSpPr>
+          <p:cNvPr id="3" name="Notes Placeholder 2"/>
+          <p:cNvSpPr>
+            <a:spLocks noGrp="1"/>
+          </p:cNvSpPr>
+          <p:nvPr>
+            <p:ph type="body" idx="1"/>
+          </p:nvPr>
+        </p:nvSpPr>
+        <p:spPr/>
+        <p:txBody>
+          <a:bodyPr/>
+          <a:lstStyle/>
+          <a:p>
+            <a:r>
+              <a:rPr lang="en-US" dirty="0"/>
+              <a:t>Leading with limitations builds credibility. Do not bury these.</a:t>
+            </a:r>
+            <a:endParaRPr lang="en-US" dirty="0"/>
+          </a:p>
+        </p:txBody>
+      </p:sp>
+      <p:sp>
+        <p:nvSpPr>
+          <p:cNvPr id="4" name="Slide Number Placeholder 3"/>
+          <p:cNvSpPr>
+            <a:spLocks noGrp="1"/>
+          </p:cNvSpPr>
+          <p:nvPr>
+            <p:ph type="sldNum" sz="quarter" idx="10"/>
+          </p:nvPr>
+        </p:nvSpPr>
+        <p:spPr/>
+        <p:txBody>
+          <a:bodyPr/>
+          <a:lstStyle/>
+          <a:p>
+            <a:fld id="{F7021451-1387-4CA6-816F-3879F97B5CBC}" type="slidenum">
+              <a:rPr lang="en-US"/>
+              <a:t>13</a:t>
             </a:fld>
             <a:endParaRPr lang="en-US"/>
           </a:p>
@@ -4132,6 +4221,2037 @@
     <p:bg>
       <p:bgPr>
         <a:solidFill>
+          <a:srgbClr val="FFFFFF"/>
+        </a:solidFill>
+      </p:bgPr>
+    </p:bg>
+    <p:spTree>
+      <p:nvGrpSpPr>
+        <p:cNvPr id="1" name=""/>
+        <p:cNvGrpSpPr/>
+        <p:nvPr/>
+      </p:nvGrpSpPr>
+      <p:grpSpPr>
+        <a:xfrm>
+          <a:off x="0" y="0"/>
+          <a:ext cx="0" cy="0"/>
+          <a:chOff x="0" y="0"/>
+          <a:chExt cx="0" cy="0"/>
+        </a:xfrm>
+      </p:grpSpPr>
+      <p:sp>
+        <p:nvSpPr>
+          <p:cNvPr id="2" name="Text 0"/>
+          <p:cNvSpPr/>
+          <p:nvPr/>
+        </p:nvSpPr>
+        <p:spPr>
+          <a:xfrm>
+            <a:off x="640080" y="384048"/>
+            <a:ext cx="10881360" cy="658368"/>
+          </a:xfrm>
+          <a:prstGeom prst="rect">
+            <a:avLst/>
+          </a:prstGeom>
+          <a:noFill/>
+          <a:ln/>
+        </p:spPr>
+        <p:txBody>
+          <a:bodyPr wrap="square" lIns="0" tIns="0" rIns="0" bIns="0" rtlCol="0" anchor="ctr"/>
+          <a:lstStyle/>
+          <a:p>
+            <a:pPr indent="0" marL="0">
+              <a:buNone/>
+            </a:pPr>
+            <a:r>
+              <a:rPr lang="en-US" sz="3400" b="1" dirty="0">
+                <a:solidFill>
+                  <a:srgbClr val="01565B"/>
+                </a:solidFill>
+                <a:latin typeface="Cambria" pitchFamily="34" charset="0"/>
+                <a:ea typeface="Cambria" pitchFamily="34" charset="-122"/>
+                <a:cs typeface="Cambria" pitchFamily="34" charset="-120"/>
+              </a:rPr>
+              <a:t>Finding 4 — sicker than poverty explains</a:t>
+            </a:r>
+            <a:endParaRPr lang="en-US" sz="3400" dirty="0"/>
+          </a:p>
+        </p:txBody>
+      </p:sp>
+      <p:sp>
+        <p:nvSpPr>
+          <p:cNvPr id="3" name="Text 1"/>
+          <p:cNvSpPr/>
+          <p:nvPr/>
+        </p:nvSpPr>
+        <p:spPr>
+          <a:xfrm>
+            <a:off x="640080" y="1060704"/>
+            <a:ext cx="10881360" cy="347472"/>
+          </a:xfrm>
+          <a:prstGeom prst="rect">
+            <a:avLst/>
+          </a:prstGeom>
+          <a:noFill/>
+          <a:ln/>
+        </p:spPr>
+        <p:txBody>
+          <a:bodyPr wrap="square" lIns="0" tIns="0" rIns="0" bIns="0" rtlCol="0" anchor="ctr"/>
+          <a:lstStyle/>
+          <a:p>
+            <a:pPr indent="0" marL="0">
+              <a:buNone/>
+            </a:pPr>
+            <a:r>
+              <a:rPr lang="en-US" sz="1400" dirty="0">
+                <a:solidFill>
+                  <a:srgbClr val="5B6B72"/>
+                </a:solidFill>
+                <a:latin typeface="Calibri" pitchFamily="34" charset="0"/>
+                <a:ea typeface="Calibri" pitchFamily="34" charset="-122"/>
+                <a:cs typeface="Calibri" pitchFamily="34" charset="-120"/>
+              </a:rPr>
+              <a:t>Modelling need from Census socioeconomics, and studying what the model misses</a:t>
+            </a:r>
+            <a:endParaRPr lang="en-US" sz="1400" dirty="0"/>
+          </a:p>
+        </p:txBody>
+      </p:sp>
+      <p:sp>
+        <p:nvSpPr>
+          <p:cNvPr id="4" name="Text 2"/>
+          <p:cNvSpPr/>
+          <p:nvPr/>
+        </p:nvSpPr>
+        <p:spPr>
+          <a:xfrm>
+            <a:off x="640080" y="1572768"/>
+            <a:ext cx="10881360" cy="731520"/>
+          </a:xfrm>
+          <a:prstGeom prst="rect">
+            <a:avLst/>
+          </a:prstGeom>
+          <a:noFill/>
+          <a:ln/>
+        </p:spPr>
+        <p:txBody>
+          <a:bodyPr wrap="square" lIns="0" tIns="0" rIns="0" bIns="0" rtlCol="0" anchor="ctr"/>
+          <a:lstStyle/>
+          <a:p>
+            <a:pPr indent="0" marL="0">
+              <a:lnSpc>
+                <a:spcPts val="2100"/>
+              </a:lnSpc>
+              <a:buNone/>
+            </a:pPr>
+            <a:r>
+              <a:rPr lang="en-US" sz="1400" dirty="0">
+                <a:solidFill>
+                  <a:srgbClr val="16232A"/>
+                </a:solidFill>
+                <a:latin typeface="Calibri" pitchFamily="34" charset="0"/>
+                <a:ea typeface="Calibri" pitchFamily="34" charset="-122"/>
+                <a:cs typeface="Calibri" pitchFamily="34" charset="-120"/>
+              </a:rPr>
+              <a:t>The need index says HOW BAD outcomes are. It cannot separate a district that is unhealthy because it is poor from one that is unhealthy beyond what its poverty explains — and a facility plausibly helps the second far more.</a:t>
+            </a:r>
+            <a:endParaRPr lang="en-US" sz="1400" dirty="0"/>
+          </a:p>
+        </p:txBody>
+      </p:sp>
+      <p:graphicFrame>
+        <p:nvGraphicFramePr>
+          <p:cNvPr id="13" name="Table 0"/>
+          <p:cNvGraphicFramePr>
+            <a:graphicFrameLocks noGrp="1"/>
+          </p:cNvGraphicFramePr>
+          <p:nvPr>
+            <p:extLst>
+              <p:ext uri="{D42A27DB-BD31-4B8C-83A1-F6EECF244321}">
+                <p14:modId xmlns:p14="http://schemas.microsoft.com/office/powerpoint/2010/main" val="1579011935"/>
+              </p:ext>
+            </p:extLst>
+          </p:nvPr>
+        </p:nvGraphicFramePr>
+        <p:xfrm>
+          <a:off x="640080" y="2423160"/>
+          <a:ext cx="6675120" cy="914400"/>
+        </p:xfrm>
+        <a:graphic>
+          <a:graphicData uri="http://schemas.openxmlformats.org/drawingml/2006/table">
+            <a:tbl>
+              <a:tblPr/>
+              <a:tblGrid>
+                <a:gridCol w="2286000"/>
+                <a:gridCol w="1371600"/>
+                <a:gridCol w="1005840"/>
+                <a:gridCol w="1005840"/>
+                <a:gridCol w="1005840"/>
+              </a:tblGrid>
+              <a:tr h="365760">
+                <a:tc>
+                  <a:txBody>
+                    <a:bodyPr/>
+                    <a:lstStyle/>
+                    <a:p>
+                      <a:pPr indent="0" marL="0">
+                        <a:buNone/>
+                      </a:pPr>
+                      <a:r>
+                        <a:rPr lang="en-US" sz="1250" b="1" dirty="0">
+                          <a:solidFill>
+                            <a:srgbClr val="FFFFFF"/>
+                          </a:solidFill>
+                          <a:latin typeface="Calibri" pitchFamily="34" charset="0"/>
+                          <a:ea typeface="Calibri" pitchFamily="34" charset="-122"/>
+                          <a:cs typeface="Calibri" pitchFamily="34" charset="-120"/>
+                        </a:rPr>
+                        <a:t>District</a:t>
+                      </a:r>
+                      <a:endParaRPr lang="en-US" sz="1250" dirty="0">
+                        <a:latin typeface="Calibri" charset="0"/>
+                        <a:ea typeface="Calibri" charset="0"/>
+                        <a:cs typeface="Calibri" charset="0"/>
+                      </a:endParaRPr>
+                    </a:p>
+                  </a:txBody>
+                  <a:tcPr marL="76200" marR="76200" marT="76200" marB="76200" anchor="ctr">
+                    <a:lnL w="6350" cap="flat" cmpd="sng" algn="ctr">
+                      <a:solidFill>
+                        <a:srgbClr val="D3E0DE"/>
+                      </a:solidFill>
+                      <a:prstDash val="solid"/>
+                      <a:round/>
+                      <a:headEnd type="none" w="med" len="med"/>
+                      <a:tailEnd type="none" w="med" len="med"/>
+                    </a:lnL>
+                    <a:lnR w="6350" cap="flat" cmpd="sng" algn="ctr">
+                      <a:solidFill>
+                        <a:srgbClr val="D3E0DE"/>
+                      </a:solidFill>
+                      <a:prstDash val="solid"/>
+                      <a:round/>
+                      <a:headEnd type="none" w="med" len="med"/>
+                      <a:tailEnd type="none" w="med" len="med"/>
+                    </a:lnR>
+                    <a:lnT w="6350" cap="flat" cmpd="sng" algn="ctr">
+                      <a:solidFill>
+                        <a:srgbClr val="D3E0DE"/>
+                      </a:solidFill>
+                      <a:prstDash val="solid"/>
+                      <a:round/>
+                      <a:headEnd type="none" w="med" len="med"/>
+                      <a:tailEnd type="none" w="med" len="med"/>
+                    </a:lnT>
+                    <a:lnB w="6350" cap="flat" cmpd="sng" algn="ctr">
+                      <a:solidFill>
+                        <a:srgbClr val="D3E0DE"/>
+                      </a:solidFill>
+                      <a:prstDash val="solid"/>
+                      <a:round/>
+                      <a:headEnd type="none" w="med" len="med"/>
+                      <a:tailEnd type="none" w="med" len="med"/>
+                    </a:lnB>
+                    <a:solidFill>
+                      <a:srgbClr val="01565B"/>
+                    </a:solidFill>
+                  </a:tcPr>
+                </a:tc>
+                <a:tc>
+                  <a:txBody>
+                    <a:bodyPr/>
+                    <a:lstStyle/>
+                    <a:p>
+                      <a:pPr indent="0" marL="0">
+                        <a:buNone/>
+                      </a:pPr>
+                      <a:r>
+                        <a:rPr lang="en-US" sz="1250" b="1" dirty="0">
+                          <a:solidFill>
+                            <a:srgbClr val="FFFFFF"/>
+                          </a:solidFill>
+                          <a:latin typeface="Calibri" pitchFamily="34" charset="0"/>
+                          <a:ea typeface="Calibri" pitchFamily="34" charset="-122"/>
+                          <a:cs typeface="Calibri" pitchFamily="34" charset="-120"/>
+                        </a:rPr>
+                        <a:t>State</a:t>
+                      </a:r>
+                      <a:endParaRPr lang="en-US" sz="1250" dirty="0">
+                        <a:latin typeface="Calibri" charset="0"/>
+                        <a:ea typeface="Calibri" charset="0"/>
+                        <a:cs typeface="Calibri" charset="0"/>
+                      </a:endParaRPr>
+                    </a:p>
+                  </a:txBody>
+                  <a:tcPr marL="76200" marR="76200" marT="76200" marB="76200" anchor="ctr">
+                    <a:lnL w="6350" cap="flat" cmpd="sng" algn="ctr">
+                      <a:solidFill>
+                        <a:srgbClr val="D3E0DE"/>
+                      </a:solidFill>
+                      <a:prstDash val="solid"/>
+                      <a:round/>
+                      <a:headEnd type="none" w="med" len="med"/>
+                      <a:tailEnd type="none" w="med" len="med"/>
+                    </a:lnL>
+                    <a:lnR w="6350" cap="flat" cmpd="sng" algn="ctr">
+                      <a:solidFill>
+                        <a:srgbClr val="D3E0DE"/>
+                      </a:solidFill>
+                      <a:prstDash val="solid"/>
+                      <a:round/>
+                      <a:headEnd type="none" w="med" len="med"/>
+                      <a:tailEnd type="none" w="med" len="med"/>
+                    </a:lnR>
+                    <a:lnT w="6350" cap="flat" cmpd="sng" algn="ctr">
+                      <a:solidFill>
+                        <a:srgbClr val="D3E0DE"/>
+                      </a:solidFill>
+                      <a:prstDash val="solid"/>
+                      <a:round/>
+                      <a:headEnd type="none" w="med" len="med"/>
+                      <a:tailEnd type="none" w="med" len="med"/>
+                    </a:lnT>
+                    <a:lnB w="6350" cap="flat" cmpd="sng" algn="ctr">
+                      <a:solidFill>
+                        <a:srgbClr val="D3E0DE"/>
+                      </a:solidFill>
+                      <a:prstDash val="solid"/>
+                      <a:round/>
+                      <a:headEnd type="none" w="med" len="med"/>
+                      <a:tailEnd type="none" w="med" len="med"/>
+                    </a:lnB>
+                    <a:solidFill>
+                      <a:srgbClr val="01565B"/>
+                    </a:solidFill>
+                  </a:tcPr>
+                </a:tc>
+                <a:tc>
+                  <a:txBody>
+                    <a:bodyPr/>
+                    <a:lstStyle/>
+                    <a:p>
+                      <a:pPr indent="0" marL="0">
+                        <a:buNone/>
+                      </a:pPr>
+                      <a:r>
+                        <a:rPr lang="en-US" sz="1250" b="1" dirty="0">
+                          <a:solidFill>
+                            <a:srgbClr val="FFFFFF"/>
+                          </a:solidFill>
+                          <a:latin typeface="Calibri" pitchFamily="34" charset="0"/>
+                          <a:ea typeface="Calibri" pitchFamily="34" charset="-122"/>
+                          <a:cs typeface="Calibri" pitchFamily="34" charset="-120"/>
+                        </a:rPr>
+                        <a:t>Actual</a:t>
+                      </a:r>
+                      <a:endParaRPr lang="en-US" sz="1250" dirty="0">
+                        <a:latin typeface="Calibri" charset="0"/>
+                        <a:ea typeface="Calibri" charset="0"/>
+                        <a:cs typeface="Calibri" charset="0"/>
+                      </a:endParaRPr>
+                    </a:p>
+                  </a:txBody>
+                  <a:tcPr marL="76200" marR="76200" marT="76200" marB="76200" anchor="ctr">
+                    <a:lnL w="6350" cap="flat" cmpd="sng" algn="ctr">
+                      <a:solidFill>
+                        <a:srgbClr val="D3E0DE"/>
+                      </a:solidFill>
+                      <a:prstDash val="solid"/>
+                      <a:round/>
+                      <a:headEnd type="none" w="med" len="med"/>
+                      <a:tailEnd type="none" w="med" len="med"/>
+                    </a:lnL>
+                    <a:lnR w="6350" cap="flat" cmpd="sng" algn="ctr">
+                      <a:solidFill>
+                        <a:srgbClr val="D3E0DE"/>
+                      </a:solidFill>
+                      <a:prstDash val="solid"/>
+                      <a:round/>
+                      <a:headEnd type="none" w="med" len="med"/>
+                      <a:tailEnd type="none" w="med" len="med"/>
+                    </a:lnR>
+                    <a:lnT w="6350" cap="flat" cmpd="sng" algn="ctr">
+                      <a:solidFill>
+                        <a:srgbClr val="D3E0DE"/>
+                      </a:solidFill>
+                      <a:prstDash val="solid"/>
+                      <a:round/>
+                      <a:headEnd type="none" w="med" len="med"/>
+                      <a:tailEnd type="none" w="med" len="med"/>
+                    </a:lnT>
+                    <a:lnB w="6350" cap="flat" cmpd="sng" algn="ctr">
+                      <a:solidFill>
+                        <a:srgbClr val="D3E0DE"/>
+                      </a:solidFill>
+                      <a:prstDash val="solid"/>
+                      <a:round/>
+                      <a:headEnd type="none" w="med" len="med"/>
+                      <a:tailEnd type="none" w="med" len="med"/>
+                    </a:lnB>
+                    <a:solidFill>
+                      <a:srgbClr val="01565B"/>
+                    </a:solidFill>
+                  </a:tcPr>
+                </a:tc>
+                <a:tc>
+                  <a:txBody>
+                    <a:bodyPr/>
+                    <a:lstStyle/>
+                    <a:p>
+                      <a:pPr indent="0" marL="0">
+                        <a:buNone/>
+                      </a:pPr>
+                      <a:r>
+                        <a:rPr lang="en-US" sz="1250" b="1" dirty="0">
+                          <a:solidFill>
+                            <a:srgbClr val="FFFFFF"/>
+                          </a:solidFill>
+                          <a:latin typeface="Calibri" pitchFamily="34" charset="0"/>
+                          <a:ea typeface="Calibri" pitchFamily="34" charset="-122"/>
+                          <a:cs typeface="Calibri" pitchFamily="34" charset="-120"/>
+                        </a:rPr>
+                        <a:t>Predicted</a:t>
+                      </a:r>
+                      <a:endParaRPr lang="en-US" sz="1250" dirty="0">
+                        <a:latin typeface="Calibri" charset="0"/>
+                        <a:ea typeface="Calibri" charset="0"/>
+                        <a:cs typeface="Calibri" charset="0"/>
+                      </a:endParaRPr>
+                    </a:p>
+                  </a:txBody>
+                  <a:tcPr marL="76200" marR="76200" marT="76200" marB="76200" anchor="ctr">
+                    <a:lnL w="6350" cap="flat" cmpd="sng" algn="ctr">
+                      <a:solidFill>
+                        <a:srgbClr val="D3E0DE"/>
+                      </a:solidFill>
+                      <a:prstDash val="solid"/>
+                      <a:round/>
+                      <a:headEnd type="none" w="med" len="med"/>
+                      <a:tailEnd type="none" w="med" len="med"/>
+                    </a:lnL>
+                    <a:lnR w="6350" cap="flat" cmpd="sng" algn="ctr">
+                      <a:solidFill>
+                        <a:srgbClr val="D3E0DE"/>
+                      </a:solidFill>
+                      <a:prstDash val="solid"/>
+                      <a:round/>
+                      <a:headEnd type="none" w="med" len="med"/>
+                      <a:tailEnd type="none" w="med" len="med"/>
+                    </a:lnR>
+                    <a:lnT w="6350" cap="flat" cmpd="sng" algn="ctr">
+                      <a:solidFill>
+                        <a:srgbClr val="D3E0DE"/>
+                      </a:solidFill>
+                      <a:prstDash val="solid"/>
+                      <a:round/>
+                      <a:headEnd type="none" w="med" len="med"/>
+                      <a:tailEnd type="none" w="med" len="med"/>
+                    </a:lnT>
+                    <a:lnB w="6350" cap="flat" cmpd="sng" algn="ctr">
+                      <a:solidFill>
+                        <a:srgbClr val="D3E0DE"/>
+                      </a:solidFill>
+                      <a:prstDash val="solid"/>
+                      <a:round/>
+                      <a:headEnd type="none" w="med" len="med"/>
+                      <a:tailEnd type="none" w="med" len="med"/>
+                    </a:lnB>
+                    <a:solidFill>
+                      <a:srgbClr val="01565B"/>
+                    </a:solidFill>
+                  </a:tcPr>
+                </a:tc>
+                <a:tc>
+                  <a:txBody>
+                    <a:bodyPr/>
+                    <a:lstStyle/>
+                    <a:p>
+                      <a:pPr indent="0" marL="0">
+                        <a:buNone/>
+                      </a:pPr>
+                      <a:r>
+                        <a:rPr lang="en-US" sz="1250" b="1" dirty="0">
+                          <a:solidFill>
+                            <a:srgbClr val="FFFFFF"/>
+                          </a:solidFill>
+                          <a:latin typeface="Calibri" pitchFamily="34" charset="0"/>
+                          <a:ea typeface="Calibri" pitchFamily="34" charset="-122"/>
+                          <a:cs typeface="Calibri" pitchFamily="34" charset="-120"/>
+                        </a:rPr>
+                        <a:t>Residual</a:t>
+                      </a:r>
+                      <a:endParaRPr lang="en-US" sz="1250" dirty="0">
+                        <a:latin typeface="Calibri" charset="0"/>
+                        <a:ea typeface="Calibri" charset="0"/>
+                        <a:cs typeface="Calibri" charset="0"/>
+                      </a:endParaRPr>
+                    </a:p>
+                  </a:txBody>
+                  <a:tcPr marL="76200" marR="76200" marT="76200" marB="76200" anchor="ctr">
+                    <a:lnL w="6350" cap="flat" cmpd="sng" algn="ctr">
+                      <a:solidFill>
+                        <a:srgbClr val="D3E0DE"/>
+                      </a:solidFill>
+                      <a:prstDash val="solid"/>
+                      <a:round/>
+                      <a:headEnd type="none" w="med" len="med"/>
+                      <a:tailEnd type="none" w="med" len="med"/>
+                    </a:lnL>
+                    <a:lnR w="6350" cap="flat" cmpd="sng" algn="ctr">
+                      <a:solidFill>
+                        <a:srgbClr val="D3E0DE"/>
+                      </a:solidFill>
+                      <a:prstDash val="solid"/>
+                      <a:round/>
+                      <a:headEnd type="none" w="med" len="med"/>
+                      <a:tailEnd type="none" w="med" len="med"/>
+                    </a:lnR>
+                    <a:lnT w="6350" cap="flat" cmpd="sng" algn="ctr">
+                      <a:solidFill>
+                        <a:srgbClr val="D3E0DE"/>
+                      </a:solidFill>
+                      <a:prstDash val="solid"/>
+                      <a:round/>
+                      <a:headEnd type="none" w="med" len="med"/>
+                      <a:tailEnd type="none" w="med" len="med"/>
+                    </a:lnT>
+                    <a:lnB w="6350" cap="flat" cmpd="sng" algn="ctr">
+                      <a:solidFill>
+                        <a:srgbClr val="D3E0DE"/>
+                      </a:solidFill>
+                      <a:prstDash val="solid"/>
+                      <a:round/>
+                      <a:headEnd type="none" w="med" len="med"/>
+                      <a:tailEnd type="none" w="med" len="med"/>
+                    </a:lnB>
+                    <a:solidFill>
+                      <a:srgbClr val="01565B"/>
+                    </a:solidFill>
+                  </a:tcPr>
+                </a:tc>
+              </a:tr>
+              <a:tr h="365760">
+                <a:tc>
+                  <a:txBody>
+                    <a:bodyPr/>
+                    <a:lstStyle/>
+                    <a:p>
+                      <a:pPr indent="0" marL="0">
+                        <a:buNone/>
+                      </a:pPr>
+                      <a:r>
+                        <a:rPr lang="en-US" sz="1250" dirty="0">
+                          <a:solidFill>
+                            <a:srgbClr val="16232A"/>
+                          </a:solidFill>
+                          <a:latin typeface="Calibri" pitchFamily="34" charset="0"/>
+                          <a:ea typeface="Calibri" pitchFamily="34" charset="-122"/>
+                          <a:cs typeface="Calibri" pitchFamily="34" charset="-120"/>
+                        </a:rPr>
+                        <a:t>Kamrup Metropolitan</a:t>
+                      </a:r>
+                      <a:endParaRPr lang="en-US" sz="1250" dirty="0">
+                        <a:latin typeface="Calibri" charset="0"/>
+                        <a:ea typeface="Calibri" charset="0"/>
+                        <a:cs typeface="Calibri" charset="0"/>
+                      </a:endParaRPr>
+                    </a:p>
+                  </a:txBody>
+                  <a:tcPr marL="76200" marR="76200" marT="76200" marB="76200" anchor="ctr">
+                    <a:lnL w="6350" cap="flat" cmpd="sng" algn="ctr">
+                      <a:solidFill>
+                        <a:srgbClr val="D3E0DE"/>
+                      </a:solidFill>
+                      <a:prstDash val="solid"/>
+                      <a:round/>
+                      <a:headEnd type="none" w="med" len="med"/>
+                      <a:tailEnd type="none" w="med" len="med"/>
+                    </a:lnL>
+                    <a:lnR w="6350" cap="flat" cmpd="sng" algn="ctr">
+                      <a:solidFill>
+                        <a:srgbClr val="D3E0DE"/>
+                      </a:solidFill>
+                      <a:prstDash val="solid"/>
+                      <a:round/>
+                      <a:headEnd type="none" w="med" len="med"/>
+                      <a:tailEnd type="none" w="med" len="med"/>
+                    </a:lnR>
+                    <a:lnT w="6350" cap="flat" cmpd="sng" algn="ctr">
+                      <a:solidFill>
+                        <a:srgbClr val="D3E0DE"/>
+                      </a:solidFill>
+                      <a:prstDash val="solid"/>
+                      <a:round/>
+                      <a:headEnd type="none" w="med" len="med"/>
+                      <a:tailEnd type="none" w="med" len="med"/>
+                    </a:lnT>
+                    <a:lnB w="6350" cap="flat" cmpd="sng" algn="ctr">
+                      <a:solidFill>
+                        <a:srgbClr val="D3E0DE"/>
+                      </a:solidFill>
+                      <a:prstDash val="solid"/>
+                      <a:round/>
+                      <a:headEnd type="none" w="med" len="med"/>
+                      <a:tailEnd type="none" w="med" len="med"/>
+                    </a:lnB>
+                  </a:tcPr>
+                </a:tc>
+                <a:tc>
+                  <a:txBody>
+                    <a:bodyPr/>
+                    <a:lstStyle/>
+                    <a:p>
+                      <a:pPr indent="0" marL="0">
+                        <a:buNone/>
+                      </a:pPr>
+                      <a:r>
+                        <a:rPr lang="en-US" sz="1250" dirty="0">
+                          <a:solidFill>
+                            <a:srgbClr val="16232A"/>
+                          </a:solidFill>
+                          <a:latin typeface="Calibri" pitchFamily="34" charset="0"/>
+                          <a:ea typeface="Calibri" pitchFamily="34" charset="-122"/>
+                          <a:cs typeface="Calibri" pitchFamily="34" charset="-120"/>
+                        </a:rPr>
+                        <a:t>Assam</a:t>
+                      </a:r>
+                      <a:endParaRPr lang="en-US" sz="1250" dirty="0">
+                        <a:latin typeface="Calibri" charset="0"/>
+                        <a:ea typeface="Calibri" charset="0"/>
+                        <a:cs typeface="Calibri" charset="0"/>
+                      </a:endParaRPr>
+                    </a:p>
+                  </a:txBody>
+                  <a:tcPr marL="76200" marR="76200" marT="76200" marB="76200" anchor="ctr">
+                    <a:lnL w="6350" cap="flat" cmpd="sng" algn="ctr">
+                      <a:solidFill>
+                        <a:srgbClr val="D3E0DE"/>
+                      </a:solidFill>
+                      <a:prstDash val="solid"/>
+                      <a:round/>
+                      <a:headEnd type="none" w="med" len="med"/>
+                      <a:tailEnd type="none" w="med" len="med"/>
+                    </a:lnL>
+                    <a:lnR w="6350" cap="flat" cmpd="sng" algn="ctr">
+                      <a:solidFill>
+                        <a:srgbClr val="D3E0DE"/>
+                      </a:solidFill>
+                      <a:prstDash val="solid"/>
+                      <a:round/>
+                      <a:headEnd type="none" w="med" len="med"/>
+                      <a:tailEnd type="none" w="med" len="med"/>
+                    </a:lnR>
+                    <a:lnT w="6350" cap="flat" cmpd="sng" algn="ctr">
+                      <a:solidFill>
+                        <a:srgbClr val="D3E0DE"/>
+                      </a:solidFill>
+                      <a:prstDash val="solid"/>
+                      <a:round/>
+                      <a:headEnd type="none" w="med" len="med"/>
+                      <a:tailEnd type="none" w="med" len="med"/>
+                    </a:lnT>
+                    <a:lnB w="6350" cap="flat" cmpd="sng" algn="ctr">
+                      <a:solidFill>
+                        <a:srgbClr val="D3E0DE"/>
+                      </a:solidFill>
+                      <a:prstDash val="solid"/>
+                      <a:round/>
+                      <a:headEnd type="none" w="med" len="med"/>
+                      <a:tailEnd type="none" w="med" len="med"/>
+                    </a:lnB>
+                  </a:tcPr>
+                </a:tc>
+                <a:tc>
+                  <a:txBody>
+                    <a:bodyPr/>
+                    <a:lstStyle/>
+                    <a:p>
+                      <a:pPr indent="0" marL="0">
+                        <a:buNone/>
+                      </a:pPr>
+                      <a:r>
+                        <a:rPr lang="en-US" sz="1250" dirty="0">
+                          <a:solidFill>
+                            <a:srgbClr val="16232A"/>
+                          </a:solidFill>
+                          <a:latin typeface="Calibri" pitchFamily="34" charset="0"/>
+                          <a:ea typeface="Calibri" pitchFamily="34" charset="-122"/>
+                          <a:cs typeface="Calibri" pitchFamily="34" charset="-120"/>
+                        </a:rPr>
+                        <a:t>0.622</a:t>
+                      </a:r>
+                      <a:endParaRPr lang="en-US" sz="1250" dirty="0">
+                        <a:latin typeface="Calibri" charset="0"/>
+                        <a:ea typeface="Calibri" charset="0"/>
+                        <a:cs typeface="Calibri" charset="0"/>
+                      </a:endParaRPr>
+                    </a:p>
+                  </a:txBody>
+                  <a:tcPr marL="76200" marR="76200" marT="76200" marB="76200" anchor="ctr">
+                    <a:lnL w="6350" cap="flat" cmpd="sng" algn="ctr">
+                      <a:solidFill>
+                        <a:srgbClr val="D3E0DE"/>
+                      </a:solidFill>
+                      <a:prstDash val="solid"/>
+                      <a:round/>
+                      <a:headEnd type="none" w="med" len="med"/>
+                      <a:tailEnd type="none" w="med" len="med"/>
+                    </a:lnL>
+                    <a:lnR w="6350" cap="flat" cmpd="sng" algn="ctr">
+                      <a:solidFill>
+                        <a:srgbClr val="D3E0DE"/>
+                      </a:solidFill>
+                      <a:prstDash val="solid"/>
+                      <a:round/>
+                      <a:headEnd type="none" w="med" len="med"/>
+                      <a:tailEnd type="none" w="med" len="med"/>
+                    </a:lnR>
+                    <a:lnT w="6350" cap="flat" cmpd="sng" algn="ctr">
+                      <a:solidFill>
+                        <a:srgbClr val="D3E0DE"/>
+                      </a:solidFill>
+                      <a:prstDash val="solid"/>
+                      <a:round/>
+                      <a:headEnd type="none" w="med" len="med"/>
+                      <a:tailEnd type="none" w="med" len="med"/>
+                    </a:lnT>
+                    <a:lnB w="6350" cap="flat" cmpd="sng" algn="ctr">
+                      <a:solidFill>
+                        <a:srgbClr val="D3E0DE"/>
+                      </a:solidFill>
+                      <a:prstDash val="solid"/>
+                      <a:round/>
+                      <a:headEnd type="none" w="med" len="med"/>
+                      <a:tailEnd type="none" w="med" len="med"/>
+                    </a:lnB>
+                  </a:tcPr>
+                </a:tc>
+                <a:tc>
+                  <a:txBody>
+                    <a:bodyPr/>
+                    <a:lstStyle/>
+                    <a:p>
+                      <a:pPr indent="0" marL="0">
+                        <a:buNone/>
+                      </a:pPr>
+                      <a:r>
+                        <a:rPr lang="en-US" sz="1250" dirty="0">
+                          <a:solidFill>
+                            <a:srgbClr val="16232A"/>
+                          </a:solidFill>
+                          <a:latin typeface="Calibri" pitchFamily="34" charset="0"/>
+                          <a:ea typeface="Calibri" pitchFamily="34" charset="-122"/>
+                          <a:cs typeface="Calibri" pitchFamily="34" charset="-120"/>
+                        </a:rPr>
+                        <a:t>0.171</a:t>
+                      </a:r>
+                      <a:endParaRPr lang="en-US" sz="1250" dirty="0">
+                        <a:latin typeface="Calibri" charset="0"/>
+                        <a:ea typeface="Calibri" charset="0"/>
+                        <a:cs typeface="Calibri" charset="0"/>
+                      </a:endParaRPr>
+                    </a:p>
+                  </a:txBody>
+                  <a:tcPr marL="76200" marR="76200" marT="76200" marB="76200" anchor="ctr">
+                    <a:lnL w="6350" cap="flat" cmpd="sng" algn="ctr">
+                      <a:solidFill>
+                        <a:srgbClr val="D3E0DE"/>
+                      </a:solidFill>
+                      <a:prstDash val="solid"/>
+                      <a:round/>
+                      <a:headEnd type="none" w="med" len="med"/>
+                      <a:tailEnd type="none" w="med" len="med"/>
+                    </a:lnL>
+                    <a:lnR w="6350" cap="flat" cmpd="sng" algn="ctr">
+                      <a:solidFill>
+                        <a:srgbClr val="D3E0DE"/>
+                      </a:solidFill>
+                      <a:prstDash val="solid"/>
+                      <a:round/>
+                      <a:headEnd type="none" w="med" len="med"/>
+                      <a:tailEnd type="none" w="med" len="med"/>
+                    </a:lnR>
+                    <a:lnT w="6350" cap="flat" cmpd="sng" algn="ctr">
+                      <a:solidFill>
+                        <a:srgbClr val="D3E0DE"/>
+                      </a:solidFill>
+                      <a:prstDash val="solid"/>
+                      <a:round/>
+                      <a:headEnd type="none" w="med" len="med"/>
+                      <a:tailEnd type="none" w="med" len="med"/>
+                    </a:lnT>
+                    <a:lnB w="6350" cap="flat" cmpd="sng" algn="ctr">
+                      <a:solidFill>
+                        <a:srgbClr val="D3E0DE"/>
+                      </a:solidFill>
+                      <a:prstDash val="solid"/>
+                      <a:round/>
+                      <a:headEnd type="none" w="med" len="med"/>
+                      <a:tailEnd type="none" w="med" len="med"/>
+                    </a:lnB>
+                  </a:tcPr>
+                </a:tc>
+                <a:tc>
+                  <a:txBody>
+                    <a:bodyPr/>
+                    <a:lstStyle/>
+                    <a:p>
+                      <a:pPr indent="0" marL="0">
+                        <a:buNone/>
+                      </a:pPr>
+                      <a:r>
+                        <a:rPr lang="en-US" sz="1250" dirty="0">
+                          <a:solidFill>
+                            <a:srgbClr val="16232A"/>
+                          </a:solidFill>
+                          <a:latin typeface="Calibri" pitchFamily="34" charset="0"/>
+                          <a:ea typeface="Calibri" pitchFamily="34" charset="-122"/>
+                          <a:cs typeface="Calibri" pitchFamily="34" charset="-120"/>
+                        </a:rPr>
+                        <a:t>+0.451</a:t>
+                      </a:r>
+                      <a:endParaRPr lang="en-US" sz="1250" dirty="0">
+                        <a:latin typeface="Calibri" charset="0"/>
+                        <a:ea typeface="Calibri" charset="0"/>
+                        <a:cs typeface="Calibri" charset="0"/>
+                      </a:endParaRPr>
+                    </a:p>
+                  </a:txBody>
+                  <a:tcPr marL="76200" marR="76200" marT="76200" marB="76200" anchor="ctr">
+                    <a:lnL w="6350" cap="flat" cmpd="sng" algn="ctr">
+                      <a:solidFill>
+                        <a:srgbClr val="D3E0DE"/>
+                      </a:solidFill>
+                      <a:prstDash val="solid"/>
+                      <a:round/>
+                      <a:headEnd type="none" w="med" len="med"/>
+                      <a:tailEnd type="none" w="med" len="med"/>
+                    </a:lnL>
+                    <a:lnR w="6350" cap="flat" cmpd="sng" algn="ctr">
+                      <a:solidFill>
+                        <a:srgbClr val="D3E0DE"/>
+                      </a:solidFill>
+                      <a:prstDash val="solid"/>
+                      <a:round/>
+                      <a:headEnd type="none" w="med" len="med"/>
+                      <a:tailEnd type="none" w="med" len="med"/>
+                    </a:lnR>
+                    <a:lnT w="6350" cap="flat" cmpd="sng" algn="ctr">
+                      <a:solidFill>
+                        <a:srgbClr val="D3E0DE"/>
+                      </a:solidFill>
+                      <a:prstDash val="solid"/>
+                      <a:round/>
+                      <a:headEnd type="none" w="med" len="med"/>
+                      <a:tailEnd type="none" w="med" len="med"/>
+                    </a:lnT>
+                    <a:lnB w="6350" cap="flat" cmpd="sng" algn="ctr">
+                      <a:solidFill>
+                        <a:srgbClr val="D3E0DE"/>
+                      </a:solidFill>
+                      <a:prstDash val="solid"/>
+                      <a:round/>
+                      <a:headEnd type="none" w="med" len="med"/>
+                      <a:tailEnd type="none" w="med" len="med"/>
+                    </a:lnB>
+                  </a:tcPr>
+                </a:tc>
+              </a:tr>
+              <a:tr h="365760">
+                <a:tc>
+                  <a:txBody>
+                    <a:bodyPr/>
+                    <a:lstStyle/>
+                    <a:p>
+                      <a:pPr indent="0" marL="0">
+                        <a:buNone/>
+                      </a:pPr>
+                      <a:r>
+                        <a:rPr lang="en-US" sz="1250" dirty="0">
+                          <a:solidFill>
+                            <a:srgbClr val="16232A"/>
+                          </a:solidFill>
+                          <a:latin typeface="Calibri" pitchFamily="34" charset="0"/>
+                          <a:ea typeface="Calibri" pitchFamily="34" charset="-122"/>
+                          <a:cs typeface="Calibri" pitchFamily="34" charset="-120"/>
+                        </a:rPr>
+                        <a:t>Mewat</a:t>
+                      </a:r>
+                      <a:endParaRPr lang="en-US" sz="1250" dirty="0">
+                        <a:latin typeface="Calibri" charset="0"/>
+                        <a:ea typeface="Calibri" charset="0"/>
+                        <a:cs typeface="Calibri" charset="0"/>
+                      </a:endParaRPr>
+                    </a:p>
+                  </a:txBody>
+                  <a:tcPr marL="76200" marR="76200" marT="76200" marB="76200" anchor="ctr">
+                    <a:lnL w="6350" cap="flat" cmpd="sng" algn="ctr">
+                      <a:solidFill>
+                        <a:srgbClr val="D3E0DE"/>
+                      </a:solidFill>
+                      <a:prstDash val="solid"/>
+                      <a:round/>
+                      <a:headEnd type="none" w="med" len="med"/>
+                      <a:tailEnd type="none" w="med" len="med"/>
+                    </a:lnL>
+                    <a:lnR w="6350" cap="flat" cmpd="sng" algn="ctr">
+                      <a:solidFill>
+                        <a:srgbClr val="D3E0DE"/>
+                      </a:solidFill>
+                      <a:prstDash val="solid"/>
+                      <a:round/>
+                      <a:headEnd type="none" w="med" len="med"/>
+                      <a:tailEnd type="none" w="med" len="med"/>
+                    </a:lnR>
+                    <a:lnT w="6350" cap="flat" cmpd="sng" algn="ctr">
+                      <a:solidFill>
+                        <a:srgbClr val="D3E0DE"/>
+                      </a:solidFill>
+                      <a:prstDash val="solid"/>
+                      <a:round/>
+                      <a:headEnd type="none" w="med" len="med"/>
+                      <a:tailEnd type="none" w="med" len="med"/>
+                    </a:lnT>
+                    <a:lnB w="6350" cap="flat" cmpd="sng" algn="ctr">
+                      <a:solidFill>
+                        <a:srgbClr val="D3E0DE"/>
+                      </a:solidFill>
+                      <a:prstDash val="solid"/>
+                      <a:round/>
+                      <a:headEnd type="none" w="med" len="med"/>
+                      <a:tailEnd type="none" w="med" len="med"/>
+                    </a:lnB>
+                  </a:tcPr>
+                </a:tc>
+                <a:tc>
+                  <a:txBody>
+                    <a:bodyPr/>
+                    <a:lstStyle/>
+                    <a:p>
+                      <a:pPr indent="0" marL="0">
+                        <a:buNone/>
+                      </a:pPr>
+                      <a:r>
+                        <a:rPr lang="en-US" sz="1250" dirty="0">
+                          <a:solidFill>
+                            <a:srgbClr val="16232A"/>
+                          </a:solidFill>
+                          <a:latin typeface="Calibri" pitchFamily="34" charset="0"/>
+                          <a:ea typeface="Calibri" pitchFamily="34" charset="-122"/>
+                          <a:cs typeface="Calibri" pitchFamily="34" charset="-120"/>
+                        </a:rPr>
+                        <a:t>Haryana</a:t>
+                      </a:r>
+                      <a:endParaRPr lang="en-US" sz="1250" dirty="0">
+                        <a:latin typeface="Calibri" charset="0"/>
+                        <a:ea typeface="Calibri" charset="0"/>
+                        <a:cs typeface="Calibri" charset="0"/>
+                      </a:endParaRPr>
+                    </a:p>
+                  </a:txBody>
+                  <a:tcPr marL="76200" marR="76200" marT="76200" marB="76200" anchor="ctr">
+                    <a:lnL w="6350" cap="flat" cmpd="sng" algn="ctr">
+                      <a:solidFill>
+                        <a:srgbClr val="D3E0DE"/>
+                      </a:solidFill>
+                      <a:prstDash val="solid"/>
+                      <a:round/>
+                      <a:headEnd type="none" w="med" len="med"/>
+                      <a:tailEnd type="none" w="med" len="med"/>
+                    </a:lnL>
+                    <a:lnR w="6350" cap="flat" cmpd="sng" algn="ctr">
+                      <a:solidFill>
+                        <a:srgbClr val="D3E0DE"/>
+                      </a:solidFill>
+                      <a:prstDash val="solid"/>
+                      <a:round/>
+                      <a:headEnd type="none" w="med" len="med"/>
+                      <a:tailEnd type="none" w="med" len="med"/>
+                    </a:lnR>
+                    <a:lnT w="6350" cap="flat" cmpd="sng" algn="ctr">
+                      <a:solidFill>
+                        <a:srgbClr val="D3E0DE"/>
+                      </a:solidFill>
+                      <a:prstDash val="solid"/>
+                      <a:round/>
+                      <a:headEnd type="none" w="med" len="med"/>
+                      <a:tailEnd type="none" w="med" len="med"/>
+                    </a:lnT>
+                    <a:lnB w="6350" cap="flat" cmpd="sng" algn="ctr">
+                      <a:solidFill>
+                        <a:srgbClr val="D3E0DE"/>
+                      </a:solidFill>
+                      <a:prstDash val="solid"/>
+                      <a:round/>
+                      <a:headEnd type="none" w="med" len="med"/>
+                      <a:tailEnd type="none" w="med" len="med"/>
+                    </a:lnB>
+                  </a:tcPr>
+                </a:tc>
+                <a:tc>
+                  <a:txBody>
+                    <a:bodyPr/>
+                    <a:lstStyle/>
+                    <a:p>
+                      <a:pPr indent="0" marL="0">
+                        <a:buNone/>
+                      </a:pPr>
+                      <a:r>
+                        <a:rPr lang="en-US" sz="1250" dirty="0">
+                          <a:solidFill>
+                            <a:srgbClr val="16232A"/>
+                          </a:solidFill>
+                          <a:latin typeface="Calibri" pitchFamily="34" charset="0"/>
+                          <a:ea typeface="Calibri" pitchFamily="34" charset="-122"/>
+                          <a:cs typeface="Calibri" pitchFamily="34" charset="-120"/>
+                        </a:rPr>
+                        <a:t>0.835</a:t>
+                      </a:r>
+                      <a:endParaRPr lang="en-US" sz="1250" dirty="0">
+                        <a:latin typeface="Calibri" charset="0"/>
+                        <a:ea typeface="Calibri" charset="0"/>
+                        <a:cs typeface="Calibri" charset="0"/>
+                      </a:endParaRPr>
+                    </a:p>
+                  </a:txBody>
+                  <a:tcPr marL="76200" marR="76200" marT="76200" marB="76200" anchor="ctr">
+                    <a:lnL w="6350" cap="flat" cmpd="sng" algn="ctr">
+                      <a:solidFill>
+                        <a:srgbClr val="D3E0DE"/>
+                      </a:solidFill>
+                      <a:prstDash val="solid"/>
+                      <a:round/>
+                      <a:headEnd type="none" w="med" len="med"/>
+                      <a:tailEnd type="none" w="med" len="med"/>
+                    </a:lnL>
+                    <a:lnR w="6350" cap="flat" cmpd="sng" algn="ctr">
+                      <a:solidFill>
+                        <a:srgbClr val="D3E0DE"/>
+                      </a:solidFill>
+                      <a:prstDash val="solid"/>
+                      <a:round/>
+                      <a:headEnd type="none" w="med" len="med"/>
+                      <a:tailEnd type="none" w="med" len="med"/>
+                    </a:lnR>
+                    <a:lnT w="6350" cap="flat" cmpd="sng" algn="ctr">
+                      <a:solidFill>
+                        <a:srgbClr val="D3E0DE"/>
+                      </a:solidFill>
+                      <a:prstDash val="solid"/>
+                      <a:round/>
+                      <a:headEnd type="none" w="med" len="med"/>
+                      <a:tailEnd type="none" w="med" len="med"/>
+                    </a:lnT>
+                    <a:lnB w="6350" cap="flat" cmpd="sng" algn="ctr">
+                      <a:solidFill>
+                        <a:srgbClr val="D3E0DE"/>
+                      </a:solidFill>
+                      <a:prstDash val="solid"/>
+                      <a:round/>
+                      <a:headEnd type="none" w="med" len="med"/>
+                      <a:tailEnd type="none" w="med" len="med"/>
+                    </a:lnB>
+                  </a:tcPr>
+                </a:tc>
+                <a:tc>
+                  <a:txBody>
+                    <a:bodyPr/>
+                    <a:lstStyle/>
+                    <a:p>
+                      <a:pPr indent="0" marL="0">
+                        <a:buNone/>
+                      </a:pPr>
+                      <a:r>
+                        <a:rPr lang="en-US" sz="1250" dirty="0">
+                          <a:solidFill>
+                            <a:srgbClr val="16232A"/>
+                          </a:solidFill>
+                          <a:latin typeface="Calibri" pitchFamily="34" charset="0"/>
+                          <a:ea typeface="Calibri" pitchFamily="34" charset="-122"/>
+                          <a:cs typeface="Calibri" pitchFamily="34" charset="-120"/>
+                        </a:rPr>
+                        <a:t>0.461</a:t>
+                      </a:r>
+                      <a:endParaRPr lang="en-US" sz="1250" dirty="0">
+                        <a:latin typeface="Calibri" charset="0"/>
+                        <a:ea typeface="Calibri" charset="0"/>
+                        <a:cs typeface="Calibri" charset="0"/>
+                      </a:endParaRPr>
+                    </a:p>
+                  </a:txBody>
+                  <a:tcPr marL="76200" marR="76200" marT="76200" marB="76200" anchor="ctr">
+                    <a:lnL w="6350" cap="flat" cmpd="sng" algn="ctr">
+                      <a:solidFill>
+                        <a:srgbClr val="D3E0DE"/>
+                      </a:solidFill>
+                      <a:prstDash val="solid"/>
+                      <a:round/>
+                      <a:headEnd type="none" w="med" len="med"/>
+                      <a:tailEnd type="none" w="med" len="med"/>
+                    </a:lnL>
+                    <a:lnR w="6350" cap="flat" cmpd="sng" algn="ctr">
+                      <a:solidFill>
+                        <a:srgbClr val="D3E0DE"/>
+                      </a:solidFill>
+                      <a:prstDash val="solid"/>
+                      <a:round/>
+                      <a:headEnd type="none" w="med" len="med"/>
+                      <a:tailEnd type="none" w="med" len="med"/>
+                    </a:lnR>
+                    <a:lnT w="6350" cap="flat" cmpd="sng" algn="ctr">
+                      <a:solidFill>
+                        <a:srgbClr val="D3E0DE"/>
+                      </a:solidFill>
+                      <a:prstDash val="solid"/>
+                      <a:round/>
+                      <a:headEnd type="none" w="med" len="med"/>
+                      <a:tailEnd type="none" w="med" len="med"/>
+                    </a:lnT>
+                    <a:lnB w="6350" cap="flat" cmpd="sng" algn="ctr">
+                      <a:solidFill>
+                        <a:srgbClr val="D3E0DE"/>
+                      </a:solidFill>
+                      <a:prstDash val="solid"/>
+                      <a:round/>
+                      <a:headEnd type="none" w="med" len="med"/>
+                      <a:tailEnd type="none" w="med" len="med"/>
+                    </a:lnB>
+                  </a:tcPr>
+                </a:tc>
+                <a:tc>
+                  <a:txBody>
+                    <a:bodyPr/>
+                    <a:lstStyle/>
+                    <a:p>
+                      <a:pPr indent="0" marL="0">
+                        <a:buNone/>
+                      </a:pPr>
+                      <a:r>
+                        <a:rPr lang="en-US" sz="1250" dirty="0">
+                          <a:solidFill>
+                            <a:srgbClr val="16232A"/>
+                          </a:solidFill>
+                          <a:latin typeface="Calibri" pitchFamily="34" charset="0"/>
+                          <a:ea typeface="Calibri" pitchFamily="34" charset="-122"/>
+                          <a:cs typeface="Calibri" pitchFamily="34" charset="-120"/>
+                        </a:rPr>
+                        <a:t>+0.374</a:t>
+                      </a:r>
+                      <a:endParaRPr lang="en-US" sz="1250" dirty="0">
+                        <a:latin typeface="Calibri" charset="0"/>
+                        <a:ea typeface="Calibri" charset="0"/>
+                        <a:cs typeface="Calibri" charset="0"/>
+                      </a:endParaRPr>
+                    </a:p>
+                  </a:txBody>
+                  <a:tcPr marL="76200" marR="76200" marT="76200" marB="76200" anchor="ctr">
+                    <a:lnL w="6350" cap="flat" cmpd="sng" algn="ctr">
+                      <a:solidFill>
+                        <a:srgbClr val="D3E0DE"/>
+                      </a:solidFill>
+                      <a:prstDash val="solid"/>
+                      <a:round/>
+                      <a:headEnd type="none" w="med" len="med"/>
+                      <a:tailEnd type="none" w="med" len="med"/>
+                    </a:lnL>
+                    <a:lnR w="6350" cap="flat" cmpd="sng" algn="ctr">
+                      <a:solidFill>
+                        <a:srgbClr val="D3E0DE"/>
+                      </a:solidFill>
+                      <a:prstDash val="solid"/>
+                      <a:round/>
+                      <a:headEnd type="none" w="med" len="med"/>
+                      <a:tailEnd type="none" w="med" len="med"/>
+                    </a:lnR>
+                    <a:lnT w="6350" cap="flat" cmpd="sng" algn="ctr">
+                      <a:solidFill>
+                        <a:srgbClr val="D3E0DE"/>
+                      </a:solidFill>
+                      <a:prstDash val="solid"/>
+                      <a:round/>
+                      <a:headEnd type="none" w="med" len="med"/>
+                      <a:tailEnd type="none" w="med" len="med"/>
+                    </a:lnT>
+                    <a:lnB w="6350" cap="flat" cmpd="sng" algn="ctr">
+                      <a:solidFill>
+                        <a:srgbClr val="D3E0DE"/>
+                      </a:solidFill>
+                      <a:prstDash val="solid"/>
+                      <a:round/>
+                      <a:headEnd type="none" w="med" len="med"/>
+                      <a:tailEnd type="none" w="med" len="med"/>
+                    </a:lnB>
+                  </a:tcPr>
+                </a:tc>
+              </a:tr>
+              <a:tr h="365760">
+                <a:tc>
+                  <a:txBody>
+                    <a:bodyPr/>
+                    <a:lstStyle/>
+                    <a:p>
+                      <a:pPr indent="0" marL="0">
+                        <a:buNone/>
+                      </a:pPr>
+                      <a:r>
+                        <a:rPr lang="en-US" sz="1250" dirty="0">
+                          <a:solidFill>
+                            <a:srgbClr val="16232A"/>
+                          </a:solidFill>
+                          <a:latin typeface="Calibri" pitchFamily="34" charset="0"/>
+                          <a:ea typeface="Calibri" pitchFamily="34" charset="-122"/>
+                          <a:cs typeface="Calibri" pitchFamily="34" charset="-120"/>
+                        </a:rPr>
+                        <a:t>Deoghar</a:t>
+                      </a:r>
+                      <a:endParaRPr lang="en-US" sz="1250" dirty="0">
+                        <a:latin typeface="Calibri" charset="0"/>
+                        <a:ea typeface="Calibri" charset="0"/>
+                        <a:cs typeface="Calibri" charset="0"/>
+                      </a:endParaRPr>
+                    </a:p>
+                  </a:txBody>
+                  <a:tcPr marL="76200" marR="76200" marT="76200" marB="76200" anchor="ctr">
+                    <a:lnL w="6350" cap="flat" cmpd="sng" algn="ctr">
+                      <a:solidFill>
+                        <a:srgbClr val="D3E0DE"/>
+                      </a:solidFill>
+                      <a:prstDash val="solid"/>
+                      <a:round/>
+                      <a:headEnd type="none" w="med" len="med"/>
+                      <a:tailEnd type="none" w="med" len="med"/>
+                    </a:lnL>
+                    <a:lnR w="6350" cap="flat" cmpd="sng" algn="ctr">
+                      <a:solidFill>
+                        <a:srgbClr val="D3E0DE"/>
+                      </a:solidFill>
+                      <a:prstDash val="solid"/>
+                      <a:round/>
+                      <a:headEnd type="none" w="med" len="med"/>
+                      <a:tailEnd type="none" w="med" len="med"/>
+                    </a:lnR>
+                    <a:lnT w="6350" cap="flat" cmpd="sng" algn="ctr">
+                      <a:solidFill>
+                        <a:srgbClr val="D3E0DE"/>
+                      </a:solidFill>
+                      <a:prstDash val="solid"/>
+                      <a:round/>
+                      <a:headEnd type="none" w="med" len="med"/>
+                      <a:tailEnd type="none" w="med" len="med"/>
+                    </a:lnT>
+                    <a:lnB w="6350" cap="flat" cmpd="sng" algn="ctr">
+                      <a:solidFill>
+                        <a:srgbClr val="D3E0DE"/>
+                      </a:solidFill>
+                      <a:prstDash val="solid"/>
+                      <a:round/>
+                      <a:headEnd type="none" w="med" len="med"/>
+                      <a:tailEnd type="none" w="med" len="med"/>
+                    </a:lnB>
+                  </a:tcPr>
+                </a:tc>
+                <a:tc>
+                  <a:txBody>
+                    <a:bodyPr/>
+                    <a:lstStyle/>
+                    <a:p>
+                      <a:pPr indent="0" marL="0">
+                        <a:buNone/>
+                      </a:pPr>
+                      <a:r>
+                        <a:rPr lang="en-US" sz="1250" dirty="0">
+                          <a:solidFill>
+                            <a:srgbClr val="16232A"/>
+                          </a:solidFill>
+                          <a:latin typeface="Calibri" pitchFamily="34" charset="0"/>
+                          <a:ea typeface="Calibri" pitchFamily="34" charset="-122"/>
+                          <a:cs typeface="Calibri" pitchFamily="34" charset="-120"/>
+                        </a:rPr>
+                        <a:t>Jharkhand</a:t>
+                      </a:r>
+                      <a:endParaRPr lang="en-US" sz="1250" dirty="0">
+                        <a:latin typeface="Calibri" charset="0"/>
+                        <a:ea typeface="Calibri" charset="0"/>
+                        <a:cs typeface="Calibri" charset="0"/>
+                      </a:endParaRPr>
+                    </a:p>
+                  </a:txBody>
+                  <a:tcPr marL="76200" marR="76200" marT="76200" marB="76200" anchor="ctr">
+                    <a:lnL w="6350" cap="flat" cmpd="sng" algn="ctr">
+                      <a:solidFill>
+                        <a:srgbClr val="D3E0DE"/>
+                      </a:solidFill>
+                      <a:prstDash val="solid"/>
+                      <a:round/>
+                      <a:headEnd type="none" w="med" len="med"/>
+                      <a:tailEnd type="none" w="med" len="med"/>
+                    </a:lnL>
+                    <a:lnR w="6350" cap="flat" cmpd="sng" algn="ctr">
+                      <a:solidFill>
+                        <a:srgbClr val="D3E0DE"/>
+                      </a:solidFill>
+                      <a:prstDash val="solid"/>
+                      <a:round/>
+                      <a:headEnd type="none" w="med" len="med"/>
+                      <a:tailEnd type="none" w="med" len="med"/>
+                    </a:lnR>
+                    <a:lnT w="6350" cap="flat" cmpd="sng" algn="ctr">
+                      <a:solidFill>
+                        <a:srgbClr val="D3E0DE"/>
+                      </a:solidFill>
+                      <a:prstDash val="solid"/>
+                      <a:round/>
+                      <a:headEnd type="none" w="med" len="med"/>
+                      <a:tailEnd type="none" w="med" len="med"/>
+                    </a:lnT>
+                    <a:lnB w="6350" cap="flat" cmpd="sng" algn="ctr">
+                      <a:solidFill>
+                        <a:srgbClr val="D3E0DE"/>
+                      </a:solidFill>
+                      <a:prstDash val="solid"/>
+                      <a:round/>
+                      <a:headEnd type="none" w="med" len="med"/>
+                      <a:tailEnd type="none" w="med" len="med"/>
+                    </a:lnB>
+                  </a:tcPr>
+                </a:tc>
+                <a:tc>
+                  <a:txBody>
+                    <a:bodyPr/>
+                    <a:lstStyle/>
+                    <a:p>
+                      <a:pPr indent="0" marL="0">
+                        <a:buNone/>
+                      </a:pPr>
+                      <a:r>
+                        <a:rPr lang="en-US" sz="1250" dirty="0">
+                          <a:solidFill>
+                            <a:srgbClr val="16232A"/>
+                          </a:solidFill>
+                          <a:latin typeface="Calibri" pitchFamily="34" charset="0"/>
+                          <a:ea typeface="Calibri" pitchFamily="34" charset="-122"/>
+                          <a:cs typeface="Calibri" pitchFamily="34" charset="-120"/>
+                        </a:rPr>
+                        <a:t>0.919</a:t>
+                      </a:r>
+                      <a:endParaRPr lang="en-US" sz="1250" dirty="0">
+                        <a:latin typeface="Calibri" charset="0"/>
+                        <a:ea typeface="Calibri" charset="0"/>
+                        <a:cs typeface="Calibri" charset="0"/>
+                      </a:endParaRPr>
+                    </a:p>
+                  </a:txBody>
+                  <a:tcPr marL="76200" marR="76200" marT="76200" marB="76200" anchor="ctr">
+                    <a:lnL w="6350" cap="flat" cmpd="sng" algn="ctr">
+                      <a:solidFill>
+                        <a:srgbClr val="D3E0DE"/>
+                      </a:solidFill>
+                      <a:prstDash val="solid"/>
+                      <a:round/>
+                      <a:headEnd type="none" w="med" len="med"/>
+                      <a:tailEnd type="none" w="med" len="med"/>
+                    </a:lnL>
+                    <a:lnR w="6350" cap="flat" cmpd="sng" algn="ctr">
+                      <a:solidFill>
+                        <a:srgbClr val="D3E0DE"/>
+                      </a:solidFill>
+                      <a:prstDash val="solid"/>
+                      <a:round/>
+                      <a:headEnd type="none" w="med" len="med"/>
+                      <a:tailEnd type="none" w="med" len="med"/>
+                    </a:lnR>
+                    <a:lnT w="6350" cap="flat" cmpd="sng" algn="ctr">
+                      <a:solidFill>
+                        <a:srgbClr val="D3E0DE"/>
+                      </a:solidFill>
+                      <a:prstDash val="solid"/>
+                      <a:round/>
+                      <a:headEnd type="none" w="med" len="med"/>
+                      <a:tailEnd type="none" w="med" len="med"/>
+                    </a:lnT>
+                    <a:lnB w="6350" cap="flat" cmpd="sng" algn="ctr">
+                      <a:solidFill>
+                        <a:srgbClr val="D3E0DE"/>
+                      </a:solidFill>
+                      <a:prstDash val="solid"/>
+                      <a:round/>
+                      <a:headEnd type="none" w="med" len="med"/>
+                      <a:tailEnd type="none" w="med" len="med"/>
+                    </a:lnB>
+                  </a:tcPr>
+                </a:tc>
+                <a:tc>
+                  <a:txBody>
+                    <a:bodyPr/>
+                    <a:lstStyle/>
+                    <a:p>
+                      <a:pPr indent="0" marL="0">
+                        <a:buNone/>
+                      </a:pPr>
+                      <a:r>
+                        <a:rPr lang="en-US" sz="1250" dirty="0">
+                          <a:solidFill>
+                            <a:srgbClr val="16232A"/>
+                          </a:solidFill>
+                          <a:latin typeface="Calibri" pitchFamily="34" charset="0"/>
+                          <a:ea typeface="Calibri" pitchFamily="34" charset="-122"/>
+                          <a:cs typeface="Calibri" pitchFamily="34" charset="-120"/>
+                        </a:rPr>
+                        <a:t>0.584</a:t>
+                      </a:r>
+                      <a:endParaRPr lang="en-US" sz="1250" dirty="0">
+                        <a:latin typeface="Calibri" charset="0"/>
+                        <a:ea typeface="Calibri" charset="0"/>
+                        <a:cs typeface="Calibri" charset="0"/>
+                      </a:endParaRPr>
+                    </a:p>
+                  </a:txBody>
+                  <a:tcPr marL="76200" marR="76200" marT="76200" marB="76200" anchor="ctr">
+                    <a:lnL w="6350" cap="flat" cmpd="sng" algn="ctr">
+                      <a:solidFill>
+                        <a:srgbClr val="D3E0DE"/>
+                      </a:solidFill>
+                      <a:prstDash val="solid"/>
+                      <a:round/>
+                      <a:headEnd type="none" w="med" len="med"/>
+                      <a:tailEnd type="none" w="med" len="med"/>
+                    </a:lnL>
+                    <a:lnR w="6350" cap="flat" cmpd="sng" algn="ctr">
+                      <a:solidFill>
+                        <a:srgbClr val="D3E0DE"/>
+                      </a:solidFill>
+                      <a:prstDash val="solid"/>
+                      <a:round/>
+                      <a:headEnd type="none" w="med" len="med"/>
+                      <a:tailEnd type="none" w="med" len="med"/>
+                    </a:lnR>
+                    <a:lnT w="6350" cap="flat" cmpd="sng" algn="ctr">
+                      <a:solidFill>
+                        <a:srgbClr val="D3E0DE"/>
+                      </a:solidFill>
+                      <a:prstDash val="solid"/>
+                      <a:round/>
+                      <a:headEnd type="none" w="med" len="med"/>
+                      <a:tailEnd type="none" w="med" len="med"/>
+                    </a:lnT>
+                    <a:lnB w="6350" cap="flat" cmpd="sng" algn="ctr">
+                      <a:solidFill>
+                        <a:srgbClr val="D3E0DE"/>
+                      </a:solidFill>
+                      <a:prstDash val="solid"/>
+                      <a:round/>
+                      <a:headEnd type="none" w="med" len="med"/>
+                      <a:tailEnd type="none" w="med" len="med"/>
+                    </a:lnB>
+                  </a:tcPr>
+                </a:tc>
+                <a:tc>
+                  <a:txBody>
+                    <a:bodyPr/>
+                    <a:lstStyle/>
+                    <a:p>
+                      <a:pPr indent="0" marL="0">
+                        <a:buNone/>
+                      </a:pPr>
+                      <a:r>
+                        <a:rPr lang="en-US" sz="1250" dirty="0">
+                          <a:solidFill>
+                            <a:srgbClr val="16232A"/>
+                          </a:solidFill>
+                          <a:latin typeface="Calibri" pitchFamily="34" charset="0"/>
+                          <a:ea typeface="Calibri" pitchFamily="34" charset="-122"/>
+                          <a:cs typeface="Calibri" pitchFamily="34" charset="-120"/>
+                        </a:rPr>
+                        <a:t>+0.335</a:t>
+                      </a:r>
+                      <a:endParaRPr lang="en-US" sz="1250" dirty="0">
+                        <a:latin typeface="Calibri" charset="0"/>
+                        <a:ea typeface="Calibri" charset="0"/>
+                        <a:cs typeface="Calibri" charset="0"/>
+                      </a:endParaRPr>
+                    </a:p>
+                  </a:txBody>
+                  <a:tcPr marL="76200" marR="76200" marT="76200" marB="76200" anchor="ctr">
+                    <a:lnL w="6350" cap="flat" cmpd="sng" algn="ctr">
+                      <a:solidFill>
+                        <a:srgbClr val="D3E0DE"/>
+                      </a:solidFill>
+                      <a:prstDash val="solid"/>
+                      <a:round/>
+                      <a:headEnd type="none" w="med" len="med"/>
+                      <a:tailEnd type="none" w="med" len="med"/>
+                    </a:lnL>
+                    <a:lnR w="6350" cap="flat" cmpd="sng" algn="ctr">
+                      <a:solidFill>
+                        <a:srgbClr val="D3E0DE"/>
+                      </a:solidFill>
+                      <a:prstDash val="solid"/>
+                      <a:round/>
+                      <a:headEnd type="none" w="med" len="med"/>
+                      <a:tailEnd type="none" w="med" len="med"/>
+                    </a:lnR>
+                    <a:lnT w="6350" cap="flat" cmpd="sng" algn="ctr">
+                      <a:solidFill>
+                        <a:srgbClr val="D3E0DE"/>
+                      </a:solidFill>
+                      <a:prstDash val="solid"/>
+                      <a:round/>
+                      <a:headEnd type="none" w="med" len="med"/>
+                      <a:tailEnd type="none" w="med" len="med"/>
+                    </a:lnT>
+                    <a:lnB w="6350" cap="flat" cmpd="sng" algn="ctr">
+                      <a:solidFill>
+                        <a:srgbClr val="D3E0DE"/>
+                      </a:solidFill>
+                      <a:prstDash val="solid"/>
+                      <a:round/>
+                      <a:headEnd type="none" w="med" len="med"/>
+                      <a:tailEnd type="none" w="med" len="med"/>
+                    </a:lnB>
+                  </a:tcPr>
+                </a:tc>
+              </a:tr>
+              <a:tr h="365760">
+                <a:tc>
+                  <a:txBody>
+                    <a:bodyPr/>
+                    <a:lstStyle/>
+                    <a:p>
+                      <a:pPr indent="0" marL="0">
+                        <a:buNone/>
+                      </a:pPr>
+                      <a:r>
+                        <a:rPr lang="en-US" sz="1250" dirty="0">
+                          <a:solidFill>
+                            <a:srgbClr val="16232A"/>
+                          </a:solidFill>
+                          <a:latin typeface="Calibri" pitchFamily="34" charset="0"/>
+                          <a:ea typeface="Calibri" pitchFamily="34" charset="-122"/>
+                          <a:cs typeface="Calibri" pitchFamily="34" charset="-120"/>
+                        </a:rPr>
+                        <a:t>Patna</a:t>
+                      </a:r>
+                      <a:endParaRPr lang="en-US" sz="1250" dirty="0">
+                        <a:latin typeface="Calibri" charset="0"/>
+                        <a:ea typeface="Calibri" charset="0"/>
+                        <a:cs typeface="Calibri" charset="0"/>
+                      </a:endParaRPr>
+                    </a:p>
+                  </a:txBody>
+                  <a:tcPr marL="76200" marR="76200" marT="76200" marB="76200" anchor="ctr">
+                    <a:lnL w="6350" cap="flat" cmpd="sng" algn="ctr">
+                      <a:solidFill>
+                        <a:srgbClr val="D3E0DE"/>
+                      </a:solidFill>
+                      <a:prstDash val="solid"/>
+                      <a:round/>
+                      <a:headEnd type="none" w="med" len="med"/>
+                      <a:tailEnd type="none" w="med" len="med"/>
+                    </a:lnL>
+                    <a:lnR w="6350" cap="flat" cmpd="sng" algn="ctr">
+                      <a:solidFill>
+                        <a:srgbClr val="D3E0DE"/>
+                      </a:solidFill>
+                      <a:prstDash val="solid"/>
+                      <a:round/>
+                      <a:headEnd type="none" w="med" len="med"/>
+                      <a:tailEnd type="none" w="med" len="med"/>
+                    </a:lnR>
+                    <a:lnT w="6350" cap="flat" cmpd="sng" algn="ctr">
+                      <a:solidFill>
+                        <a:srgbClr val="D3E0DE"/>
+                      </a:solidFill>
+                      <a:prstDash val="solid"/>
+                      <a:round/>
+                      <a:headEnd type="none" w="med" len="med"/>
+                      <a:tailEnd type="none" w="med" len="med"/>
+                    </a:lnT>
+                    <a:lnB w="6350" cap="flat" cmpd="sng" algn="ctr">
+                      <a:solidFill>
+                        <a:srgbClr val="D3E0DE"/>
+                      </a:solidFill>
+                      <a:prstDash val="solid"/>
+                      <a:round/>
+                      <a:headEnd type="none" w="med" len="med"/>
+                      <a:tailEnd type="none" w="med" len="med"/>
+                    </a:lnB>
+                  </a:tcPr>
+                </a:tc>
+                <a:tc>
+                  <a:txBody>
+                    <a:bodyPr/>
+                    <a:lstStyle/>
+                    <a:p>
+                      <a:pPr indent="0" marL="0">
+                        <a:buNone/>
+                      </a:pPr>
+                      <a:r>
+                        <a:rPr lang="en-US" sz="1250" dirty="0">
+                          <a:solidFill>
+                            <a:srgbClr val="16232A"/>
+                          </a:solidFill>
+                          <a:latin typeface="Calibri" pitchFamily="34" charset="0"/>
+                          <a:ea typeface="Calibri" pitchFamily="34" charset="-122"/>
+                          <a:cs typeface="Calibri" pitchFamily="34" charset="-120"/>
+                        </a:rPr>
+                        <a:t>Bihar</a:t>
+                      </a:r>
+                      <a:endParaRPr lang="en-US" sz="1250" dirty="0">
+                        <a:latin typeface="Calibri" charset="0"/>
+                        <a:ea typeface="Calibri" charset="0"/>
+                        <a:cs typeface="Calibri" charset="0"/>
+                      </a:endParaRPr>
+                    </a:p>
+                  </a:txBody>
+                  <a:tcPr marL="76200" marR="76200" marT="76200" marB="76200" anchor="ctr">
+                    <a:lnL w="6350" cap="flat" cmpd="sng" algn="ctr">
+                      <a:solidFill>
+                        <a:srgbClr val="D3E0DE"/>
+                      </a:solidFill>
+                      <a:prstDash val="solid"/>
+                      <a:round/>
+                      <a:headEnd type="none" w="med" len="med"/>
+                      <a:tailEnd type="none" w="med" len="med"/>
+                    </a:lnL>
+                    <a:lnR w="6350" cap="flat" cmpd="sng" algn="ctr">
+                      <a:solidFill>
+                        <a:srgbClr val="D3E0DE"/>
+                      </a:solidFill>
+                      <a:prstDash val="solid"/>
+                      <a:round/>
+                      <a:headEnd type="none" w="med" len="med"/>
+                      <a:tailEnd type="none" w="med" len="med"/>
+                    </a:lnR>
+                    <a:lnT w="6350" cap="flat" cmpd="sng" algn="ctr">
+                      <a:solidFill>
+                        <a:srgbClr val="D3E0DE"/>
+                      </a:solidFill>
+                      <a:prstDash val="solid"/>
+                      <a:round/>
+                      <a:headEnd type="none" w="med" len="med"/>
+                      <a:tailEnd type="none" w="med" len="med"/>
+                    </a:lnT>
+                    <a:lnB w="6350" cap="flat" cmpd="sng" algn="ctr">
+                      <a:solidFill>
+                        <a:srgbClr val="D3E0DE"/>
+                      </a:solidFill>
+                      <a:prstDash val="solid"/>
+                      <a:round/>
+                      <a:headEnd type="none" w="med" len="med"/>
+                      <a:tailEnd type="none" w="med" len="med"/>
+                    </a:lnB>
+                  </a:tcPr>
+                </a:tc>
+                <a:tc>
+                  <a:txBody>
+                    <a:bodyPr/>
+                    <a:lstStyle/>
+                    <a:p>
+                      <a:pPr indent="0" marL="0">
+                        <a:buNone/>
+                      </a:pPr>
+                      <a:r>
+                        <a:rPr lang="en-US" sz="1250" dirty="0">
+                          <a:solidFill>
+                            <a:srgbClr val="16232A"/>
+                          </a:solidFill>
+                          <a:latin typeface="Calibri" pitchFamily="34" charset="0"/>
+                          <a:ea typeface="Calibri" pitchFamily="34" charset="-122"/>
+                          <a:cs typeface="Calibri" pitchFamily="34" charset="-120"/>
+                        </a:rPr>
+                        <a:t>0.810</a:t>
+                      </a:r>
+                      <a:endParaRPr lang="en-US" sz="1250" dirty="0">
+                        <a:latin typeface="Calibri" charset="0"/>
+                        <a:ea typeface="Calibri" charset="0"/>
+                        <a:cs typeface="Calibri" charset="0"/>
+                      </a:endParaRPr>
+                    </a:p>
+                  </a:txBody>
+                  <a:tcPr marL="76200" marR="76200" marT="76200" marB="76200" anchor="ctr">
+                    <a:lnL w="6350" cap="flat" cmpd="sng" algn="ctr">
+                      <a:solidFill>
+                        <a:srgbClr val="D3E0DE"/>
+                      </a:solidFill>
+                      <a:prstDash val="solid"/>
+                      <a:round/>
+                      <a:headEnd type="none" w="med" len="med"/>
+                      <a:tailEnd type="none" w="med" len="med"/>
+                    </a:lnL>
+                    <a:lnR w="6350" cap="flat" cmpd="sng" algn="ctr">
+                      <a:solidFill>
+                        <a:srgbClr val="D3E0DE"/>
+                      </a:solidFill>
+                      <a:prstDash val="solid"/>
+                      <a:round/>
+                      <a:headEnd type="none" w="med" len="med"/>
+                      <a:tailEnd type="none" w="med" len="med"/>
+                    </a:lnR>
+                    <a:lnT w="6350" cap="flat" cmpd="sng" algn="ctr">
+                      <a:solidFill>
+                        <a:srgbClr val="D3E0DE"/>
+                      </a:solidFill>
+                      <a:prstDash val="solid"/>
+                      <a:round/>
+                      <a:headEnd type="none" w="med" len="med"/>
+                      <a:tailEnd type="none" w="med" len="med"/>
+                    </a:lnT>
+                    <a:lnB w="6350" cap="flat" cmpd="sng" algn="ctr">
+                      <a:solidFill>
+                        <a:srgbClr val="D3E0DE"/>
+                      </a:solidFill>
+                      <a:prstDash val="solid"/>
+                      <a:round/>
+                      <a:headEnd type="none" w="med" len="med"/>
+                      <a:tailEnd type="none" w="med" len="med"/>
+                    </a:lnB>
+                  </a:tcPr>
+                </a:tc>
+                <a:tc>
+                  <a:txBody>
+                    <a:bodyPr/>
+                    <a:lstStyle/>
+                    <a:p>
+                      <a:pPr indent="0" marL="0">
+                        <a:buNone/>
+                      </a:pPr>
+                      <a:r>
+                        <a:rPr lang="en-US" sz="1250" dirty="0">
+                          <a:solidFill>
+                            <a:srgbClr val="16232A"/>
+                          </a:solidFill>
+                          <a:latin typeface="Calibri" pitchFamily="34" charset="0"/>
+                          <a:ea typeface="Calibri" pitchFamily="34" charset="-122"/>
+                          <a:cs typeface="Calibri" pitchFamily="34" charset="-120"/>
+                        </a:rPr>
+                        <a:t>0.536</a:t>
+                      </a:r>
+                      <a:endParaRPr lang="en-US" sz="1250" dirty="0">
+                        <a:latin typeface="Calibri" charset="0"/>
+                        <a:ea typeface="Calibri" charset="0"/>
+                        <a:cs typeface="Calibri" charset="0"/>
+                      </a:endParaRPr>
+                    </a:p>
+                  </a:txBody>
+                  <a:tcPr marL="76200" marR="76200" marT="76200" marB="76200" anchor="ctr">
+                    <a:lnL w="6350" cap="flat" cmpd="sng" algn="ctr">
+                      <a:solidFill>
+                        <a:srgbClr val="D3E0DE"/>
+                      </a:solidFill>
+                      <a:prstDash val="solid"/>
+                      <a:round/>
+                      <a:headEnd type="none" w="med" len="med"/>
+                      <a:tailEnd type="none" w="med" len="med"/>
+                    </a:lnL>
+                    <a:lnR w="6350" cap="flat" cmpd="sng" algn="ctr">
+                      <a:solidFill>
+                        <a:srgbClr val="D3E0DE"/>
+                      </a:solidFill>
+                      <a:prstDash val="solid"/>
+                      <a:round/>
+                      <a:headEnd type="none" w="med" len="med"/>
+                      <a:tailEnd type="none" w="med" len="med"/>
+                    </a:lnR>
+                    <a:lnT w="6350" cap="flat" cmpd="sng" algn="ctr">
+                      <a:solidFill>
+                        <a:srgbClr val="D3E0DE"/>
+                      </a:solidFill>
+                      <a:prstDash val="solid"/>
+                      <a:round/>
+                      <a:headEnd type="none" w="med" len="med"/>
+                      <a:tailEnd type="none" w="med" len="med"/>
+                    </a:lnT>
+                    <a:lnB w="6350" cap="flat" cmpd="sng" algn="ctr">
+                      <a:solidFill>
+                        <a:srgbClr val="D3E0DE"/>
+                      </a:solidFill>
+                      <a:prstDash val="solid"/>
+                      <a:round/>
+                      <a:headEnd type="none" w="med" len="med"/>
+                      <a:tailEnd type="none" w="med" len="med"/>
+                    </a:lnB>
+                  </a:tcPr>
+                </a:tc>
+                <a:tc>
+                  <a:txBody>
+                    <a:bodyPr/>
+                    <a:lstStyle/>
+                    <a:p>
+                      <a:pPr indent="0" marL="0">
+                        <a:buNone/>
+                      </a:pPr>
+                      <a:r>
+                        <a:rPr lang="en-US" sz="1250" dirty="0">
+                          <a:solidFill>
+                            <a:srgbClr val="16232A"/>
+                          </a:solidFill>
+                          <a:latin typeface="Calibri" pitchFamily="34" charset="0"/>
+                          <a:ea typeface="Calibri" pitchFamily="34" charset="-122"/>
+                          <a:cs typeface="Calibri" pitchFamily="34" charset="-120"/>
+                        </a:rPr>
+                        <a:t>+0.274</a:t>
+                      </a:r>
+                      <a:endParaRPr lang="en-US" sz="1250" dirty="0">
+                        <a:latin typeface="Calibri" charset="0"/>
+                        <a:ea typeface="Calibri" charset="0"/>
+                        <a:cs typeface="Calibri" charset="0"/>
+                      </a:endParaRPr>
+                    </a:p>
+                  </a:txBody>
+                  <a:tcPr marL="76200" marR="76200" marT="76200" marB="76200" anchor="ctr">
+                    <a:lnL w="6350" cap="flat" cmpd="sng" algn="ctr">
+                      <a:solidFill>
+                        <a:srgbClr val="D3E0DE"/>
+                      </a:solidFill>
+                      <a:prstDash val="solid"/>
+                      <a:round/>
+                      <a:headEnd type="none" w="med" len="med"/>
+                      <a:tailEnd type="none" w="med" len="med"/>
+                    </a:lnL>
+                    <a:lnR w="6350" cap="flat" cmpd="sng" algn="ctr">
+                      <a:solidFill>
+                        <a:srgbClr val="D3E0DE"/>
+                      </a:solidFill>
+                      <a:prstDash val="solid"/>
+                      <a:round/>
+                      <a:headEnd type="none" w="med" len="med"/>
+                      <a:tailEnd type="none" w="med" len="med"/>
+                    </a:lnR>
+                    <a:lnT w="6350" cap="flat" cmpd="sng" algn="ctr">
+                      <a:solidFill>
+                        <a:srgbClr val="D3E0DE"/>
+                      </a:solidFill>
+                      <a:prstDash val="solid"/>
+                      <a:round/>
+                      <a:headEnd type="none" w="med" len="med"/>
+                      <a:tailEnd type="none" w="med" len="med"/>
+                    </a:lnT>
+                    <a:lnB w="6350" cap="flat" cmpd="sng" algn="ctr">
+                      <a:solidFill>
+                        <a:srgbClr val="D3E0DE"/>
+                      </a:solidFill>
+                      <a:prstDash val="solid"/>
+                      <a:round/>
+                      <a:headEnd type="none" w="med" len="med"/>
+                      <a:tailEnd type="none" w="med" len="med"/>
+                    </a:lnB>
+                  </a:tcPr>
+                </a:tc>
+              </a:tr>
+            </a:tbl>
+          </a:graphicData>
+        </a:graphic>
+      </p:graphicFrame>
+      <p:sp>
+        <p:nvSpPr>
+          <p:cNvPr id="6" name="Shape 3"/>
+          <p:cNvSpPr/>
+          <p:nvPr/>
+        </p:nvSpPr>
+        <p:spPr>
+          <a:xfrm>
+            <a:off x="7772400" y="2423160"/>
+            <a:ext cx="3749040" cy="2651760"/>
+          </a:xfrm>
+          <a:prstGeom prst="roundRect">
+            <a:avLst>
+              <a:gd name="adj" fmla="val 2069"/>
+            </a:avLst>
+          </a:prstGeom>
+          <a:solidFill>
+            <a:srgbClr val="01565B"/>
+          </a:solidFill>
+          <a:ln w="9525">
+            <a:solidFill>
+              <a:srgbClr val="D3E0DE"/>
+            </a:solidFill>
+            <a:prstDash val="solid"/>
+          </a:ln>
+          <a:effectLst>
+            <a:outerShdw sx="100000" sy="100000" kx="0" ky="0" algn="bl" rotWithShape="0" blurRad="101600" dist="12700" dir="5400000">
+              <a:srgbClr val="8FA6A4">
+                <a:alpha val="10000"/>
+              </a:srgbClr>
+            </a:outerShdw>
+          </a:effectLst>
+        </p:spPr>
+      </p:sp>
+      <p:sp>
+        <p:nvSpPr>
+          <p:cNvPr id="7" name="Text 4"/>
+          <p:cNvSpPr/>
+          <p:nvPr/>
+        </p:nvSpPr>
+        <p:spPr>
+          <a:xfrm>
+            <a:off x="8046720" y="2633472"/>
+            <a:ext cx="3200400" cy="274320"/>
+          </a:xfrm>
+          <a:prstGeom prst="rect">
+            <a:avLst/>
+          </a:prstGeom>
+          <a:noFill/>
+          <a:ln/>
+        </p:spPr>
+        <p:txBody>
+          <a:bodyPr wrap="square" lIns="0" tIns="0" rIns="0" bIns="0" rtlCol="0" anchor="ctr"/>
+          <a:lstStyle/>
+          <a:p>
+            <a:pPr indent="0" marL="0">
+              <a:buNone/>
+            </a:pPr>
+            <a:r>
+              <a:rPr lang="en-US" sz="1100" b="1" spc="100" kern="0" dirty="0">
+                <a:solidFill>
+                  <a:srgbClr val="E4572E"/>
+                </a:solidFill>
+                <a:latin typeface="Calibri" pitchFamily="34" charset="0"/>
+                <a:ea typeface="Calibri" pitchFamily="34" charset="-122"/>
+                <a:cs typeface="Calibri" pitchFamily="34" charset="-120"/>
+              </a:rPr>
+              <a:t>OUT-OF-FOLD R²</a:t>
+            </a:r>
+            <a:endParaRPr lang="en-US" sz="1100" dirty="0"/>
+          </a:p>
+        </p:txBody>
+      </p:sp>
+      <p:sp>
+        <p:nvSpPr>
+          <p:cNvPr id="8" name="Text 5"/>
+          <p:cNvSpPr/>
+          <p:nvPr/>
+        </p:nvSpPr>
+        <p:spPr>
+          <a:xfrm>
+            <a:off x="8046720" y="2971800"/>
+            <a:ext cx="3200400" cy="731520"/>
+          </a:xfrm>
+          <a:prstGeom prst="rect">
+            <a:avLst/>
+          </a:prstGeom>
+          <a:noFill/>
+          <a:ln/>
+        </p:spPr>
+        <p:txBody>
+          <a:bodyPr wrap="square" lIns="0" tIns="0" rIns="0" bIns="0" rtlCol="0" anchor="ctr"/>
+          <a:lstStyle/>
+          <a:p>
+            <a:pPr indent="0" marL="0">
+              <a:buNone/>
+            </a:pPr>
+            <a:r>
+              <a:rPr lang="en-US" sz="4400" b="1" dirty="0">
+                <a:solidFill>
+                  <a:srgbClr val="FFFFFF"/>
+                </a:solidFill>
+                <a:latin typeface="Cambria" pitchFamily="34" charset="0"/>
+                <a:ea typeface="Cambria" pitchFamily="34" charset="-122"/>
+                <a:cs typeface="Cambria" pitchFamily="34" charset="-120"/>
+              </a:rPr>
+              <a:t>0.657</a:t>
+            </a:r>
+            <a:endParaRPr lang="en-US" sz="4400" dirty="0"/>
+          </a:p>
+        </p:txBody>
+      </p:sp>
+      <p:sp>
+        <p:nvSpPr>
+          <p:cNvPr id="9" name="Text 6"/>
+          <p:cNvSpPr/>
+          <p:nvPr/>
+        </p:nvSpPr>
+        <p:spPr>
+          <a:xfrm>
+            <a:off x="8046720" y="3749040"/>
+            <a:ext cx="3200400" cy="1188720"/>
+          </a:xfrm>
+          <a:prstGeom prst="rect">
+            <a:avLst/>
+          </a:prstGeom>
+          <a:noFill/>
+          <a:ln/>
+        </p:spPr>
+        <p:txBody>
+          <a:bodyPr wrap="square" lIns="0" tIns="0" rIns="0" bIns="0" rtlCol="0" anchor="ctr"/>
+          <a:lstStyle/>
+          <a:p>
+            <a:pPr indent="0" marL="0">
+              <a:lnSpc>
+                <a:spcPts val="1700"/>
+              </a:lnSpc>
+              <a:buNone/>
+            </a:pPr>
+            <a:r>
+              <a:rPr lang="en-US" sz="1200" dirty="0">
+                <a:solidFill>
+                  <a:srgbClr val="A8CBC9"/>
+                </a:solidFill>
+                <a:latin typeface="Calibri" pitchFamily="34" charset="0"/>
+                <a:ea typeface="Calibri" pitchFamily="34" charset="-122"/>
+                <a:cs typeface="Calibri" pitchFamily="34" charset="-120"/>
+              </a:rPr>
+              <a:t>A HIGH R² would not be a good result — it would mean outcomes are fully determined by material conditions, leaving no room for a health-system signal.</a:t>
+            </a:r>
+            <a:endParaRPr lang="en-US" sz="1200" dirty="0"/>
+          </a:p>
+        </p:txBody>
+      </p:sp>
+      <p:sp>
+        <p:nvSpPr>
+          <p:cNvPr id="10" name="Text 7"/>
+          <p:cNvSpPr/>
+          <p:nvPr/>
+        </p:nvSpPr>
+        <p:spPr>
+          <a:xfrm>
+            <a:off x="640080" y="5212080"/>
+            <a:ext cx="10881360" cy="822960"/>
+          </a:xfrm>
+          <a:prstGeom prst="rect">
+            <a:avLst/>
+          </a:prstGeom>
+          <a:noFill/>
+          <a:ln/>
+        </p:spPr>
+        <p:txBody>
+          <a:bodyPr wrap="square" lIns="0" tIns="0" rIns="0" bIns="0" rtlCol="0" anchor="ctr"/>
+          <a:lstStyle/>
+          <a:p>
+            <a:pPr indent="0" marL="0">
+              <a:lnSpc>
+                <a:spcPts val="2000"/>
+              </a:lnSpc>
+              <a:buNone/>
+            </a:pPr>
+            <a:r>
+              <a:rPr lang="en-US" sz="1300" dirty="0">
+                <a:solidFill>
+                  <a:srgbClr val="16232A"/>
+                </a:solidFill>
+                <a:latin typeface="Calibri" pitchFamily="34" charset="0"/>
+                <a:ea typeface="Calibri" pitchFamily="34" charset="-122"/>
+                <a:cs typeface="Calibri" pitchFamily="34" charset="-120"/>
+              </a:rPr>
+              <a:t>Kamrup Metropolitan is Guwahati — a state capital with a strong socioeconomic profile and health outcomes far below it. Patna is another. A need ranking alone surfaces neither. The residual is NOT used to drive the allocation.</a:t>
+            </a:r>
+            <a:endParaRPr lang="en-US" sz="1300" dirty="0"/>
+          </a:p>
+        </p:txBody>
+      </p:sp>
+    </p:spTree>
+  </p:cSld>
+  <p:clrMapOvr>
+    <a:masterClrMapping/>
+  </p:clrMapOvr>
+</p:sld>
+</file>
+
+<file path=ppt/slides/slide13.xml><?xml version="1.0" encoding="utf-8"?>
+<p:sld xmlns:a="http://schemas.openxmlformats.org/drawingml/2006/main" xmlns:r="http://schemas.openxmlformats.org/officeDocument/2006/relationships" xmlns:p="http://schemas.openxmlformats.org/presentationml/2006/main">
+  <p:cSld name="Slide 13">
+    <p:bg>
+      <p:bgPr>
+        <a:solidFill>
           <a:srgbClr val="07373B"/>
         </a:solidFill>
       </p:bgPr>

</xml_diff>